<commit_message>
Add Part 5: customize the built-in overlay, choose your car
Replaces the idea of a hand-rolled Irrlicht overlay with wiring the
window's existing HUD/info-panel/profiler through config switches, and
adds a VEHICLE switch (hmmwv/sedan/citybus/gator) backed by a
build_vehicle() factory, since every Chrono::Vehicle full-vehicle model
shares the same GetVehicle()/GetSystem()/Synchronize()/Advance()
interface. Updates the README and slide deck to match.

Co-Authored-By: Claude Sonnet 5 <noreply@anthropic.com>
</commit_message>
<xml_diff>
--- a/tutorial_HIL_driver.pptx
+++ b/tutorial_HIL_driver.pptx
@@ -43,6 +43,12 @@
     <p:sldId id="288" r:id="rId40"/>
     <p:sldId id="289" r:id="rId41"/>
     <p:sldId id="290" r:id="rId42"/>
+    <p:sldId id="294" r:id="rId46"/>
+    <p:sldId id="295" r:id="rId47"/>
+    <p:sldId id="296" r:id="rId7"/>
+    <p:sldId id="297" r:id="rId6"/>
+    <p:sldId id="298" r:id="rId5"/>
+    <p:sldId id="299" r:id="rId4"/>
     <p:sldId id="291" r:id="rId43"/>
     <p:sldId id="292" r:id="rId44"/>
     <p:sldId id="293" r:id="rId45"/>
@@ -6916,6 +6922,13 @@
             </a:r>
           </a:p>
           <a:p>
+            <a:pPr lvl="1"/>
+            <a:r>
+              <a:rPr sz="1800"/>
+              <a:t>PART 5: Customize the built-in overlay and choose your car</a:t>
+            </a:r>
+          </a:p>
+          <a:p>
             <a:pPr/>
             <a:r>
               <a:rPr sz="2000"/>
@@ -11626,7 +11639,7 @@
           <a:p>
             <a:r>
               <a:rPr sz="1000"/>
-              <a:t>36</a:t>
+              <a:t>42</a:t>
             </a:r>
           </a:p>
         </p:txBody>
@@ -11740,7 +11753,7 @@
           <a:p>
             <a:r>
               <a:rPr sz="1000"/>
-              <a:t>37</a:t>
+              <a:t>43</a:t>
             </a:r>
           </a:p>
         </p:txBody>
@@ -11891,7 +11904,121 @@
           <a:p>
             <a:r>
               <a:rPr sz="1000"/>
-              <a:t>38</a:t>
+              <a:t>44</a:t>
+            </a:r>
+          </a:p>
+        </p:txBody>
+      </p:sp>
+    </p:spTree>
+  </p:cSld>
+  <p:clrMapOvr>
+    <a:masterClrMapping/>
+  </p:clrMapOvr>
+</p:sld>
+</file>
+
+<file path=ppt/slides/slide39.xml><?xml version="1.0" encoding="utf-8"?>
+<p:sld xmlns:a="http://schemas.openxmlformats.org/drawingml/2006/main" xmlns:p="http://schemas.openxmlformats.org/presentationml/2006/main" xmlns:r="http://schemas.openxmlformats.org/officeDocument/2006/relationships">
+  <p:cSld>
+    <p:spTree>
+      <p:nvGrpSpPr>
+        <p:cNvPr id="1" name=""/>
+        <p:cNvGrpSpPr/>
+        <p:nvPr/>
+      </p:nvGrpSpPr>
+      <p:grpSpPr/>
+      <p:sp>
+        <p:nvSpPr>
+          <p:cNvPr id="2" name="Title 1"/>
+          <p:cNvSpPr>
+            <a:spLocks noGrp="1"/>
+          </p:cNvSpPr>
+          <p:nvPr>
+            <p:ph type="title"/>
+          </p:nvPr>
+        </p:nvSpPr>
+        <p:spPr/>
+        <p:txBody>
+          <a:bodyPr/>
+          <a:lstStyle/>
+          <a:p>
+            <a:r>
+              <a:t>Part 5: Choose your car, customize the overlay</a:t>
+            </a:r>
+          </a:p>
+        </p:txBody>
+      </p:sp>
+      <p:sp>
+        <p:nvSpPr>
+          <p:cNvPr id="3" name="Text Placeholder 2"/>
+          <p:cNvSpPr>
+            <a:spLocks noGrp="1"/>
+          </p:cNvSpPr>
+          <p:nvPr>
+            <p:ph type="body" idx="1"/>
+          </p:nvPr>
+        </p:nvSpPr>
+        <p:spPr/>
+        <p:txBody>
+          <a:bodyPr/>
+          <a:lstStyle/>
+          <a:p/>
+        </p:txBody>
+      </p:sp>
+      <p:sp>
+        <p:nvSpPr>
+          <p:cNvPr id="4" name="TextBox 3"/>
+          <p:cNvSpPr txBox="1"/>
+          <p:nvPr/>
+        </p:nvSpPr>
+        <p:spPr>
+          <a:xfrm>
+            <a:off x="310974" y="6645811"/>
+            <a:ext cx="11644805" cy="188527"/>
+          </a:xfrm>
+          <a:prstGeom prst="rect">
+            <a:avLst/>
+          </a:prstGeom>
+          <a:noFill/>
+        </p:spPr>
+        <p:txBody>
+          <a:bodyPr wrap="none">
+            <a:spAutoFit/>
+          </a:bodyPr>
+          <a:lstStyle/>
+          <a:p>
+            <a:r>
+              <a:rPr sz="1000"/>
+              <a:t>University of Wisconsin - Madison</a:t>
+            </a:r>
+          </a:p>
+        </p:txBody>
+      </p:sp>
+      <p:sp>
+        <p:nvSpPr>
+          <p:cNvPr id="5" name="TextBox 4"/>
+          <p:cNvSpPr txBox="1"/>
+          <p:nvPr/>
+        </p:nvSpPr>
+        <p:spPr>
+          <a:xfrm>
+            <a:off x="10249563" y="6646310"/>
+            <a:ext cx="1706217" cy="188028"/>
+          </a:xfrm>
+          <a:prstGeom prst="rect">
+            <a:avLst/>
+          </a:prstGeom>
+          <a:noFill/>
+        </p:spPr>
+        <p:txBody>
+          <a:bodyPr wrap="none">
+            <a:spAutoFit/>
+          </a:bodyPr>
+          <a:lstStyle/>
+          <a:p>
+            <a:r>
+              <a:rPr sz="1000"/>
+              <a:t>36</a:t>
             </a:r>
           </a:p>
         </p:txBody>
@@ -12006,6 +12133,952 @@
             <a:r>
               <a:rPr sz="1000"/>
               <a:t>4</a:t>
+            </a:r>
+          </a:p>
+        </p:txBody>
+      </p:sp>
+    </p:spTree>
+  </p:cSld>
+  <p:clrMapOvr>
+    <a:masterClrMapping/>
+  </p:clrMapOvr>
+</p:sld>
+</file>
+
+<file path=ppt/slides/slide40.xml><?xml version="1.0" encoding="utf-8"?>
+<p:sld xmlns:a="http://schemas.openxmlformats.org/drawingml/2006/main" xmlns:p="http://schemas.openxmlformats.org/presentationml/2006/main" xmlns:r="http://schemas.openxmlformats.org/officeDocument/2006/relationships">
+  <p:cSld>
+    <p:spTree>
+      <p:nvGrpSpPr>
+        <p:cNvPr id="1" name=""/>
+        <p:cNvGrpSpPr/>
+        <p:nvPr/>
+      </p:nvGrpSpPr>
+      <p:grpSpPr/>
+      <p:sp>
+        <p:nvSpPr>
+          <p:cNvPr id="2" name="Title 1"/>
+          <p:cNvSpPr>
+            <a:spLocks noGrp="1"/>
+          </p:cNvSpPr>
+          <p:nvPr>
+            <p:ph type="title"/>
+          </p:nvPr>
+        </p:nvSpPr>
+        <p:spPr/>
+        <p:txBody>
+          <a:bodyPr/>
+          <a:lstStyle/>
+          <a:p>
+            <a:pPr/>
+            <a:r>
+              <a:rPr sz="3302"/>
+              <a:t>One interface, many vehicles - and a HUD you don't have to build</a:t>
+            </a:r>
+          </a:p>
+        </p:txBody>
+      </p:sp>
+      <p:sp>
+        <p:nvSpPr>
+          <p:cNvPr id="3" name="Content Placeholder 2"/>
+          <p:cNvSpPr>
+            <a:spLocks noGrp="1"/>
+          </p:cNvSpPr>
+          <p:nvPr>
+            <p:ph idx="1"/>
+          </p:nvPr>
+        </p:nvSpPr>
+        <p:spPr/>
+        <p:txBody>
+          <a:bodyPr wrap="square"/>
+          <a:lstStyle/>
+          <a:p>
+            <a:pPr/>
+            <a:r>
+              <a:rPr sz="2000"/>
+              <a:t>Every full-vehicle model in Chrono::Vehicle (HMMWV_Full, Sedan, CityBus, Gator, ...) shares the same interface</a:t>
+            </a:r>
+          </a:p>
+          <a:p>
+            <a:pPr/>
+            <a:r>
+              <a:rPr sz="1800">
+                <a:latin typeface="Consolas"/>
+              </a:rPr>
+              <a:t>GetVehicle()</a:t>
+            </a:r>
+            <a:r>
+              <a:rPr sz="2000"/>
+              <a:t> / </a:t>
+            </a:r>
+            <a:r>
+              <a:rPr sz="1800">
+                <a:latin typeface="Consolas"/>
+              </a:rPr>
+              <a:t>GetSystem()</a:t>
+            </a:r>
+            <a:r>
+              <a:rPr sz="2000"/>
+              <a:t> / </a:t>
+            </a:r>
+            <a:r>
+              <a:rPr sz="1800">
+                <a:latin typeface="Consolas"/>
+              </a:rPr>
+              <a:t>Synchronize()</a:t>
+            </a:r>
+            <a:r>
+              <a:rPr sz="2000"/>
+              <a:t> / </a:t>
+            </a:r>
+            <a:r>
+              <a:rPr sz="1800">
+                <a:latin typeface="Consolas"/>
+              </a:rPr>
+              <a:t>Advance()</a:t>
+            </a:r>
+            <a:r>
+              <a:rPr sz="2000"/>
+              <a:t> - the same four calls no matter which model you picked</a:t>
+            </a:r>
+          </a:p>
+          <a:p>
+            <a:pPr/>
+            <a:r>
+              <a:rPr sz="2000"/>
+              <a:t>VEHICLE picks the model; build_vehicle() is the only place that knows the differences (init height, extra setup calls)</a:t>
+            </a:r>
+          </a:p>
+          <a:p>
+            <a:pPr/>
+            <a:r>
+              <a:rPr sz="2000"/>
+              <a:t>The Irrlicht window already ships with an on-screen HUD, plus Chrono's own tabbed info panel and a profiler</a:t>
+            </a:r>
+          </a:p>
+          <a:p>
+            <a:pPr/>
+            <a:r>
+              <a:rPr sz="2000"/>
+              <a:t>None of it is hand-drawn - add or remove pieces with flags on vis, no custom overlay needed</a:t>
+            </a:r>
+          </a:p>
+        </p:txBody>
+      </p:sp>
+      <p:sp>
+        <p:nvSpPr>
+          <p:cNvPr id="4" name="TextBox 3"/>
+          <p:cNvSpPr txBox="1"/>
+          <p:nvPr/>
+        </p:nvSpPr>
+        <p:spPr>
+          <a:xfrm>
+            <a:off x="310974" y="6645811"/>
+            <a:ext cx="11644805" cy="188527"/>
+          </a:xfrm>
+          <a:prstGeom prst="rect">
+            <a:avLst/>
+          </a:prstGeom>
+          <a:noFill/>
+        </p:spPr>
+        <p:txBody>
+          <a:bodyPr wrap="none">
+            <a:spAutoFit/>
+          </a:bodyPr>
+          <a:lstStyle/>
+          <a:p>
+            <a:r>
+              <a:rPr sz="1000"/>
+              <a:t>University of Wisconsin - Madison</a:t>
+            </a:r>
+          </a:p>
+        </p:txBody>
+      </p:sp>
+      <p:sp>
+        <p:nvSpPr>
+          <p:cNvPr id="5" name="TextBox 4"/>
+          <p:cNvSpPr txBox="1"/>
+          <p:nvPr/>
+        </p:nvSpPr>
+        <p:spPr>
+          <a:xfrm>
+            <a:off x="10249563" y="6646310"/>
+            <a:ext cx="1706217" cy="188028"/>
+          </a:xfrm>
+          <a:prstGeom prst="rect">
+            <a:avLst/>
+          </a:prstGeom>
+          <a:noFill/>
+        </p:spPr>
+        <p:txBody>
+          <a:bodyPr wrap="none">
+            <a:spAutoFit/>
+          </a:bodyPr>
+          <a:lstStyle/>
+          <a:p>
+            <a:r>
+              <a:rPr sz="1000"/>
+              <a:t>37</a:t>
+            </a:r>
+          </a:p>
+        </p:txBody>
+      </p:sp>
+    </p:spTree>
+  </p:cSld>
+  <p:clrMapOvr>
+    <a:masterClrMapping/>
+  </p:clrMapOvr>
+</p:sld>
+</file>
+
+<file path=ppt/slides/slide41.xml><?xml version="1.0" encoding="utf-8"?>
+<p:sld xmlns:a="http://schemas.openxmlformats.org/drawingml/2006/main" xmlns:p="http://schemas.openxmlformats.org/presentationml/2006/main" xmlns:r="http://schemas.openxmlformats.org/officeDocument/2006/relationships">
+  <p:cSld>
+    <p:spTree>
+      <p:nvGrpSpPr>
+        <p:cNvPr id="1" name=""/>
+        <p:cNvGrpSpPr/>
+        <p:nvPr/>
+      </p:nvGrpSpPr>
+      <p:grpSpPr/>
+      <p:sp>
+        <p:nvSpPr>
+          <p:cNvPr id="2" name="Title 1"/>
+          <p:cNvSpPr>
+            <a:spLocks noGrp="1"/>
+          </p:cNvSpPr>
+          <p:nvPr>
+            <p:ph type="title"/>
+          </p:nvPr>
+        </p:nvSpPr>
+        <p:spPr/>
+        <p:txBody>
+          <a:bodyPr/>
+          <a:lstStyle/>
+          <a:p>
+            <a:r>
+              <a:t>Choose your car (Lines 284 to 292)</a:t>
+            </a:r>
+          </a:p>
+        </p:txBody>
+      </p:sp>
+      <p:sp>
+        <p:nvSpPr>
+          <p:cNvPr id="3" name="TextBox 2"/>
+          <p:cNvSpPr txBox="1"/>
+          <p:nvPr/>
+        </p:nvSpPr>
+        <p:spPr>
+          <a:xfrm>
+            <a:off x="0" y="1050000"/>
+            <a:ext cx="12192000" cy="5537200"/>
+          </a:xfrm>
+          <a:prstGeom prst="rect">
+            <a:avLst/>
+          </a:prstGeom>
+          <a:solidFill>
+            <a:srgbClr val="000000"/>
+          </a:solidFill>
+        </p:spPr>
+        <p:txBody>
+          <a:bodyPr wrap="none" lIns="300000" rIns="300000">
+            <a:noAutofit/>
+          </a:bodyPr>
+          <a:lstStyle/>
+          <a:p>
+            <a:r>
+              <a:rPr sz="1000">
+                <a:solidFill>
+                  <a:srgbClr val="CCCCCC"/>
+                </a:solidFill>
+                <a:latin typeface="Consolas"/>
+              </a:rPr>
+              <a:t>def main():</a:t>
+            </a:r>
+          </a:p>
+          <a:p>
+            <a:r>
+              <a:rPr sz="1000">
+                <a:solidFill>
+                  <a:srgbClr val="CCCCCC"/>
+                </a:solidFill>
+                <a:latin typeface="Consolas"/>
+              </a:rPr>
+              <a:t>    # -----------------------------------------------------------------------</a:t>
+            </a:r>
+          </a:p>
+          <a:p>
+            <a:r>
+              <a:rPr sz="1000">
+                <a:solidFill>
+                  <a:srgbClr val="CCCCCC"/>
+                </a:solidFill>
+                <a:latin typeface="Consolas"/>
+              </a:rPr>
+              <a:t>    # Create the vehicle (PART 5) and initialize</a:t>
+            </a:r>
+          </a:p>
+          <a:p>
+            <a:r>
+              <a:rPr sz="1000">
+                <a:solidFill>
+                  <a:srgbClr val="CCCCCC"/>
+                </a:solidFill>
+                <a:latin typeface="Consolas"/>
+              </a:rPr>
+              <a:t>    # -----------------------------------------------------------------------</a:t>
+            </a:r>
+          </a:p>
+          <a:p>
+            <a:r>
+              <a:rPr sz="1000">
+                <a:solidFill>
+                  <a:srgbClr val="CCCCCC"/>
+                </a:solidFill>
+                <a:latin typeface="Consolas"/>
+              </a:rPr>
+              <a:t>    vehicle_model, chase_dist = build_vehicle(VEHICLE)</a:t>
+            </a:r>
+          </a:p>
+          <a:p>
+            <a:r>
+              <a:rPr sz="1000">
+                <a:solidFill>
+                  <a:srgbClr val="CCCCCC"/>
+                </a:solidFill>
+                <a:latin typeface="Consolas"/>
+              </a:rPr>
+              <a:t> </a:t>
+            </a:r>
+          </a:p>
+          <a:p>
+            <a:r>
+              <a:rPr sz="1000">
+                <a:solidFill>
+                  <a:srgbClr val="CCCCCC"/>
+                </a:solidFill>
+                <a:latin typeface="Consolas"/>
+              </a:rPr>
+              <a:t>    vehicle = vehicle_model.GetVehicle()</a:t>
+            </a:r>
+          </a:p>
+          <a:p>
+            <a:r>
+              <a:rPr sz="1000">
+                <a:solidFill>
+                  <a:srgbClr val="CCCCCC"/>
+                </a:solidFill>
+                <a:latin typeface="Consolas"/>
+              </a:rPr>
+              <a:t>    system = vehicle_model.GetSystem()</a:t>
+            </a:r>
+          </a:p>
+          <a:p>
+            <a:r>
+              <a:rPr sz="1000">
+                <a:solidFill>
+                  <a:srgbClr val="CCCCCC"/>
+                </a:solidFill>
+                <a:latin typeface="Consolas"/>
+              </a:rPr>
+              <a:t>    system.SetCollisionSystemType(chrono.ChCollisionSystem.Type_BULLET)</a:t>
+            </a:r>
+          </a:p>
+        </p:txBody>
+      </p:sp>
+      <p:sp>
+        <p:nvSpPr>
+          <p:cNvPr id="4" name="TextBox 3"/>
+          <p:cNvSpPr txBox="1"/>
+          <p:nvPr/>
+        </p:nvSpPr>
+        <p:spPr>
+          <a:xfrm>
+            <a:off x="400000" y="6687200"/>
+            <a:ext cx="11392000" cy="-229200"/>
+          </a:xfrm>
+          <a:prstGeom prst="rect">
+            <a:avLst/>
+          </a:prstGeom>
+          <a:noFill/>
+        </p:spPr>
+        <p:txBody>
+          <a:bodyPr/>
+          <a:lstStyle/>
+          <a:p>
+            <a:r>
+              <a:rPr sz="1800"/>
+              <a:t>VEHICLE lives in CONFIGURATION - "hmmwv" | "sedan" | "citybus" | "gator"; everything below this line is unchanged</a:t>
+            </a:r>
+          </a:p>
+        </p:txBody>
+      </p:sp>
+      <p:sp>
+        <p:nvSpPr>
+          <p:cNvPr id="5" name="TextBox 4"/>
+          <p:cNvSpPr txBox="1"/>
+          <p:nvPr/>
+        </p:nvSpPr>
+        <p:spPr>
+          <a:xfrm>
+            <a:off x="310974" y="6645811"/>
+            <a:ext cx="11644805" cy="188527"/>
+          </a:xfrm>
+          <a:prstGeom prst="rect">
+            <a:avLst/>
+          </a:prstGeom>
+          <a:noFill/>
+        </p:spPr>
+        <p:txBody>
+          <a:bodyPr wrap="none">
+            <a:spAutoFit/>
+          </a:bodyPr>
+          <a:lstStyle/>
+          <a:p>
+            <a:r>
+              <a:rPr sz="1000"/>
+              <a:t>University of Wisconsin - Madison</a:t>
+            </a:r>
+          </a:p>
+        </p:txBody>
+      </p:sp>
+      <p:sp>
+        <p:nvSpPr>
+          <p:cNvPr id="6" name="TextBox 5"/>
+          <p:cNvSpPr txBox="1"/>
+          <p:nvPr/>
+        </p:nvSpPr>
+        <p:spPr>
+          <a:xfrm>
+            <a:off x="10249563" y="6646310"/>
+            <a:ext cx="1706217" cy="188028"/>
+          </a:xfrm>
+          <a:prstGeom prst="rect">
+            <a:avLst/>
+          </a:prstGeom>
+          <a:noFill/>
+        </p:spPr>
+        <p:txBody>
+          <a:bodyPr wrap="none">
+            <a:spAutoFit/>
+          </a:bodyPr>
+          <a:lstStyle/>
+          <a:p>
+            <a:r>
+              <a:rPr sz="1000"/>
+              <a:t>38</a:t>
+            </a:r>
+          </a:p>
+        </p:txBody>
+      </p:sp>
+    </p:spTree>
+  </p:cSld>
+  <p:clrMapOvr>
+    <a:masterClrMapping/>
+  </p:clrMapOvr>
+</p:sld>
+</file>
+
+<file path=ppt/slides/slide42.xml><?xml version="1.0" encoding="utf-8"?>
+<p:sld xmlns:a="http://schemas.openxmlformats.org/drawingml/2006/main" xmlns:p="http://schemas.openxmlformats.org/presentationml/2006/main" xmlns:r="http://schemas.openxmlformats.org/officeDocument/2006/relationships">
+  <p:cSld>
+    <p:spTree>
+      <p:nvGrpSpPr>
+        <p:cNvPr id="1" name=""/>
+        <p:cNvGrpSpPr/>
+        <p:nvPr/>
+      </p:nvGrpSpPr>
+      <p:grpSpPr/>
+      <p:sp>
+        <p:nvSpPr>
+          <p:cNvPr id="2" name="Title 1"/>
+          <p:cNvSpPr>
+            <a:spLocks noGrp="1"/>
+          </p:cNvSpPr>
+          <p:nvPr>
+            <p:ph type="title"/>
+          </p:nvPr>
+        </p:nvSpPr>
+        <p:spPr/>
+        <p:txBody>
+          <a:bodyPr/>
+          <a:lstStyle/>
+          <a:p>
+            <a:r>
+              <a:t>Add or remove overlay pieces (Lines 365 to 372)</a:t>
+            </a:r>
+          </a:p>
+        </p:txBody>
+      </p:sp>
+      <p:sp>
+        <p:nvSpPr>
+          <p:cNvPr id="3" name="TextBox 2"/>
+          <p:cNvSpPr txBox="1"/>
+          <p:nvPr/>
+        </p:nvSpPr>
+        <p:spPr>
+          <a:xfrm>
+            <a:off x="0" y="1050000"/>
+            <a:ext cx="12192000" cy="5537200"/>
+          </a:xfrm>
+          <a:prstGeom prst="rect">
+            <a:avLst/>
+          </a:prstGeom>
+          <a:solidFill>
+            <a:srgbClr val="000000"/>
+          </a:solidFill>
+        </p:spPr>
+        <p:txBody>
+          <a:bodyPr wrap="none" lIns="300000" rIns="300000">
+            <a:noAutofit/>
+          </a:bodyPr>
+          <a:lstStyle/>
+          <a:p>
+            <a:r>
+              <a:rPr sz="1000">
+                <a:solidFill>
+                  <a:srgbClr val="CCCCCC"/>
+                </a:solidFill>
+                <a:latin typeface="Consolas"/>
+              </a:rPr>
+              <a:t># PART 5: the built-in overlay - nothing here is hand-drawn, every piece</a:t>
+            </a:r>
+          </a:p>
+          <a:p>
+            <a:r>
+              <a:rPr sz="1000">
+                <a:solidFill>
+                  <a:srgbClr val="CCCCCC"/>
+                </a:solidFill>
+                <a:latin typeface="Consolas"/>
+              </a:rPr>
+              <a:t># is a flag or a method on `vis` itself</a:t>
+            </a:r>
+          </a:p>
+          <a:p>
+            <a:r>
+              <a:rPr sz="1000">
+                <a:solidFill>
+                  <a:srgbClr val="CCCCCC"/>
+                </a:solidFill>
+                <a:latin typeface="Consolas"/>
+              </a:rPr>
+              <a:t>vis.EnableStats(SHOW_VEHICLE_HUD)        # speed/steering/throttle/brake panel</a:t>
+            </a:r>
+          </a:p>
+          <a:p>
+            <a:r>
+              <a:rPr sz="1000">
+                <a:solidFill>
+                  <a:srgbClr val="CCCCCC"/>
+                </a:solidFill>
+                <a:latin typeface="Consolas"/>
+              </a:rPr>
+              <a:t>vis.SetHUDLocation(*HUD_CORNER)          # where that panel sits</a:t>
+            </a:r>
+          </a:p>
+          <a:p>
+            <a:r>
+              <a:rPr sz="1000">
+                <a:solidFill>
+                  <a:srgbClr val="CCCCCC"/>
+                </a:solidFill>
+                <a:latin typeface="Consolas"/>
+              </a:rPr>
+              <a:t>vis.ShowInfoPanel(SHOW_SIM_INFO_PANEL)   # Chrono's own tabbed info panel</a:t>
+            </a:r>
+          </a:p>
+          <a:p>
+            <a:r>
+              <a:rPr sz="1000">
+                <a:solidFill>
+                  <a:srgbClr val="CCCCCC"/>
+                </a:solidFill>
+                <a:latin typeface="Consolas"/>
+              </a:rPr>
+              <a:t>                                          # (bodies, contacts, timers); also</a:t>
+            </a:r>
+          </a:p>
+          <a:p>
+            <a:r>
+              <a:rPr sz="1000">
+                <a:solidFill>
+                  <a:srgbClr val="CCCCCC"/>
+                </a:solidFill>
+                <a:latin typeface="Consolas"/>
+              </a:rPr>
+              <a:t>                                          # toggles live with the 'i' key</a:t>
+            </a:r>
+          </a:p>
+          <a:p>
+            <a:r>
+              <a:rPr sz="1000">
+                <a:solidFill>
+                  <a:srgbClr val="CCCCCC"/>
+                </a:solidFill>
+                <a:latin typeface="Consolas"/>
+              </a:rPr>
+              <a:t>vis.ShowProfiler(SHOW_PROFILER)          # per-module timing bars</a:t>
+            </a:r>
+          </a:p>
+        </p:txBody>
+      </p:sp>
+      <p:sp>
+        <p:nvSpPr>
+          <p:cNvPr id="4" name="TextBox 3"/>
+          <p:cNvSpPr txBox="1"/>
+          <p:nvPr/>
+        </p:nvSpPr>
+        <p:spPr>
+          <a:xfrm>
+            <a:off x="400000" y="6687200"/>
+            <a:ext cx="11392000" cy="-229200"/>
+          </a:xfrm>
+          <a:prstGeom prst="rect">
+            <a:avLst/>
+          </a:prstGeom>
+          <a:noFill/>
+        </p:spPr>
+        <p:txBody>
+          <a:bodyPr/>
+          <a:lstStyle/>
+          <a:p>
+            <a:r>
+              <a:rPr sz="1800"/>
+              <a:t>SHOW_VEHICLE_HUD, HUD_CORNER, SHOW_SIM_INFO_PANEL, SHOW_PROFILER all live in CONFIGURATION, right next to VEHICLE</a:t>
+            </a:r>
+          </a:p>
+        </p:txBody>
+      </p:sp>
+      <p:sp>
+        <p:nvSpPr>
+          <p:cNvPr id="5" name="TextBox 4"/>
+          <p:cNvSpPr txBox="1"/>
+          <p:nvPr/>
+        </p:nvSpPr>
+        <p:spPr>
+          <a:xfrm>
+            <a:off x="310974" y="6645811"/>
+            <a:ext cx="11644805" cy="188527"/>
+          </a:xfrm>
+          <a:prstGeom prst="rect">
+            <a:avLst/>
+          </a:prstGeom>
+          <a:noFill/>
+        </p:spPr>
+        <p:txBody>
+          <a:bodyPr wrap="none">
+            <a:spAutoFit/>
+          </a:bodyPr>
+          <a:lstStyle/>
+          <a:p>
+            <a:r>
+              <a:rPr sz="1000"/>
+              <a:t>University of Wisconsin - Madison</a:t>
+            </a:r>
+          </a:p>
+        </p:txBody>
+      </p:sp>
+      <p:sp>
+        <p:nvSpPr>
+          <p:cNvPr id="6" name="TextBox 5"/>
+          <p:cNvSpPr txBox="1"/>
+          <p:nvPr/>
+        </p:nvSpPr>
+        <p:spPr>
+          <a:xfrm>
+            <a:off x="10249563" y="6646310"/>
+            <a:ext cx="1706217" cy="188028"/>
+          </a:xfrm>
+          <a:prstGeom prst="rect">
+            <a:avLst/>
+          </a:prstGeom>
+          <a:noFill/>
+        </p:spPr>
+        <p:txBody>
+          <a:bodyPr wrap="none">
+            <a:spAutoFit/>
+          </a:bodyPr>
+          <a:lstStyle/>
+          <a:p>
+            <a:r>
+              <a:rPr sz="1000"/>
+              <a:t>39</a:t>
+            </a:r>
+          </a:p>
+        </p:txBody>
+      </p:sp>
+    </p:spTree>
+  </p:cSld>
+  <p:clrMapOvr>
+    <a:masterClrMapping/>
+  </p:clrMapOvr>
+</p:sld>
+</file>
+
+<file path=ppt/slides/slide43.xml><?xml version="1.0" encoding="utf-8"?>
+<p:sld xmlns:a="http://schemas.openxmlformats.org/drawingml/2006/main" xmlns:p="http://schemas.openxmlformats.org/presentationml/2006/main" xmlns:r="http://schemas.openxmlformats.org/officeDocument/2006/relationships">
+  <p:cSld>
+    <p:spTree>
+      <p:nvGrpSpPr>
+        <p:cNvPr id="1" name=""/>
+        <p:cNvGrpSpPr/>
+        <p:nvPr/>
+      </p:nvGrpSpPr>
+      <p:grpSpPr/>
+      <p:sp>
+        <p:nvSpPr>
+          <p:cNvPr id="2" name="Title 1"/>
+          <p:cNvSpPr>
+            <a:spLocks noGrp="1"/>
+          </p:cNvSpPr>
+          <p:nvPr>
+            <p:ph type="title"/>
+          </p:nvPr>
+        </p:nvSpPr>
+        <p:spPr/>
+        <p:txBody>
+          <a:bodyPr/>
+          <a:lstStyle/>
+          <a:p>
+            <a:pPr/>
+            <a:r>
+              <a:rPr sz="3302"/>
+              <a:t>Before running the code, please</a:t>
+            </a:r>
+          </a:p>
+        </p:txBody>
+      </p:sp>
+      <p:sp>
+        <p:nvSpPr>
+          <p:cNvPr id="3" name="Content Placeholder 2"/>
+          <p:cNvSpPr>
+            <a:spLocks noGrp="1"/>
+          </p:cNvSpPr>
+          <p:nvPr>
+            <p:ph idx="1"/>
+          </p:nvPr>
+        </p:nvSpPr>
+        <p:spPr/>
+        <p:txBody>
+          <a:bodyPr wrap="square"/>
+          <a:lstStyle/>
+          <a:p>
+            <a:pPr/>
+            <a:r>
+              <a:rPr sz="2000"/>
+              <a:t>Set VEHICLE = "citybus" (or "sedan", "gator") and re-run - same driver, same terrain, very different vehicle</a:t>
+            </a:r>
+          </a:p>
+          <a:p>
+            <a:pPr/>
+            <a:r>
+              <a:rPr sz="2000"/>
+              <a:t>Set SHOW_SIM_INFO_PANEL = True, then press the </a:t>
+            </a:r>
+            <a:r>
+              <a:rPr sz="1800">
+                <a:latin typeface="Consolas"/>
+              </a:rPr>
+              <a:t>i</a:t>
+            </a:r>
+            <a:r>
+              <a:rPr sz="2000"/>
+              <a:t> key while the sim is running - same panel, two ways to reach it</a:t>
+            </a:r>
+          </a:p>
+          <a:p>
+            <a:pPr/>
+            <a:r>
+              <a:rPr sz="2000"/>
+              <a:t>Try SHOW_VEHICLE_HUD = False - the 3D scene doesn't care, only the panel disappears</a:t>
+            </a:r>
+          </a:p>
+        </p:txBody>
+      </p:sp>
+      <p:sp>
+        <p:nvSpPr>
+          <p:cNvPr id="4" name="TextBox 3"/>
+          <p:cNvSpPr txBox="1"/>
+          <p:nvPr/>
+        </p:nvSpPr>
+        <p:spPr>
+          <a:xfrm>
+            <a:off x="310974" y="6645811"/>
+            <a:ext cx="11644805" cy="188527"/>
+          </a:xfrm>
+          <a:prstGeom prst="rect">
+            <a:avLst/>
+          </a:prstGeom>
+          <a:noFill/>
+        </p:spPr>
+        <p:txBody>
+          <a:bodyPr wrap="none">
+            <a:spAutoFit/>
+          </a:bodyPr>
+          <a:lstStyle/>
+          <a:p>
+            <a:r>
+              <a:rPr sz="1000"/>
+              <a:t>University of Wisconsin - Madison</a:t>
+            </a:r>
+          </a:p>
+        </p:txBody>
+      </p:sp>
+      <p:sp>
+        <p:nvSpPr>
+          <p:cNvPr id="5" name="TextBox 4"/>
+          <p:cNvSpPr txBox="1"/>
+          <p:nvPr/>
+        </p:nvSpPr>
+        <p:spPr>
+          <a:xfrm>
+            <a:off x="10249563" y="6646310"/>
+            <a:ext cx="1706217" cy="188028"/>
+          </a:xfrm>
+          <a:prstGeom prst="rect">
+            <a:avLst/>
+          </a:prstGeom>
+          <a:noFill/>
+        </p:spPr>
+        <p:txBody>
+          <a:bodyPr wrap="none">
+            <a:spAutoFit/>
+          </a:bodyPr>
+          <a:lstStyle/>
+          <a:p>
+            <a:r>
+              <a:rPr sz="1000"/>
+              <a:t>40</a:t>
+            </a:r>
+          </a:p>
+        </p:txBody>
+      </p:sp>
+    </p:spTree>
+  </p:cSld>
+  <p:clrMapOvr>
+    <a:masterClrMapping/>
+  </p:clrMapOvr>
+</p:sld>
+</file>
+
+<file path=ppt/slides/slide44.xml><?xml version="1.0" encoding="utf-8"?>
+<p:sld xmlns:a="http://schemas.openxmlformats.org/drawingml/2006/main" xmlns:p="http://schemas.openxmlformats.org/presentationml/2006/main" xmlns:r="http://schemas.openxmlformats.org/officeDocument/2006/relationships">
+  <p:cSld>
+    <p:spTree>
+      <p:nvGrpSpPr>
+        <p:cNvPr id="1" name=""/>
+        <p:cNvGrpSpPr/>
+        <p:nvPr/>
+      </p:nvGrpSpPr>
+      <p:grpSpPr/>
+      <p:sp>
+        <p:nvSpPr>
+          <p:cNvPr id="2" name="Title 1"/>
+          <p:cNvSpPr>
+            <a:spLocks noGrp="1"/>
+          </p:cNvSpPr>
+          <p:nvPr>
+            <p:ph type="title"/>
+          </p:nvPr>
+        </p:nvSpPr>
+        <p:spPr/>
+        <p:txBody>
+          <a:bodyPr/>
+          <a:lstStyle/>
+          <a:p>
+            <a:pPr/>
+            <a:r>
+              <a:rPr sz="3302"/>
+              <a:t>Show Time</a:t>
+            </a:r>
+          </a:p>
+        </p:txBody>
+      </p:sp>
+      <p:sp>
+        <p:nvSpPr>
+          <p:cNvPr id="3" name="Content Placeholder 2"/>
+          <p:cNvSpPr>
+            <a:spLocks noGrp="1"/>
+          </p:cNvSpPr>
+          <p:nvPr>
+            <p:ph idx="1"/>
+          </p:nvPr>
+        </p:nvSpPr>
+        <p:spPr/>
+        <p:txBody>
+          <a:bodyPr wrap="square"/>
+          <a:lstStyle/>
+          <a:p>
+            <a:pPr/>
+            <a:r>
+              <a:rPr sz="2000"/>
+              <a:t>Everyone picks a different VEHICLE and compares how the same scripted course drives an HMMWV vs. a bus vs. a Gator</a:t>
+            </a:r>
+          </a:p>
+          <a:p>
+            <a:pPr/>
+            <a:r>
+              <a:rPr sz="2000"/>
+              <a:t>Toggle SHOW_VEHICLE_HUD / SHOW_SIM_INFO_PANEL live and watch the overlay change - nothing was re-rendered by hand</a:t>
+            </a:r>
+          </a:p>
+        </p:txBody>
+      </p:sp>
+      <p:sp>
+        <p:nvSpPr>
+          <p:cNvPr id="4" name="TextBox 3"/>
+          <p:cNvSpPr txBox="1"/>
+          <p:nvPr/>
+        </p:nvSpPr>
+        <p:spPr>
+          <a:xfrm>
+            <a:off x="310974" y="6645811"/>
+            <a:ext cx="11644805" cy="188527"/>
+          </a:xfrm>
+          <a:prstGeom prst="rect">
+            <a:avLst/>
+          </a:prstGeom>
+          <a:noFill/>
+        </p:spPr>
+        <p:txBody>
+          <a:bodyPr wrap="none">
+            <a:spAutoFit/>
+          </a:bodyPr>
+          <a:lstStyle/>
+          <a:p>
+            <a:r>
+              <a:rPr sz="1000"/>
+              <a:t>University of Wisconsin - Madison</a:t>
+            </a:r>
+          </a:p>
+        </p:txBody>
+      </p:sp>
+      <p:sp>
+        <p:nvSpPr>
+          <p:cNvPr id="5" name="TextBox 4"/>
+          <p:cNvSpPr txBox="1"/>
+          <p:nvPr/>
+        </p:nvSpPr>
+        <p:spPr>
+          <a:xfrm>
+            <a:off x="10249563" y="6646310"/>
+            <a:ext cx="1706217" cy="188028"/>
+          </a:xfrm>
+          <a:prstGeom prst="rect">
+            <a:avLst/>
+          </a:prstGeom>
+          <a:noFill/>
+        </p:spPr>
+        <p:txBody>
+          <a:bodyPr wrap="none">
+            <a:spAutoFit/>
+          </a:bodyPr>
+          <a:lstStyle/>
+          <a:p>
+            <a:r>
+              <a:rPr sz="1000"/>
+              <a:t>41</a:t>
             </a:r>
           </a:p>
         </p:txBody>

</xml_diff>

<commit_message>
Fix stale Part 2 line numbers and code, predating the Part 5 update
Slides 16-17 still referenced line numbers from before build_vehicle()
and the VEHICLE config were ever added, and slide 17's code hadn't been
updated for the "gamepad" AttachDriver sharing either.

Co-Authored-By: Claude Sonnet 5 <noreply@anthropic.com>
</commit_message>
<xml_diff>
--- a/tutorial_HIL_driver.pptx
+++ b/tutorial_HIL_driver.pptx
@@ -6200,7 +6200,7 @@
           <a:p>
             <a:r>
               <a:rPr sz="2600"/>
-              <a:t>Step 1: ChInteractiveDriver (Lines 264 to 275)</a:t>
+              <a:t>Step 1: ChInteractiveDriver (Lines 296 to 307)</a:t>
             </a:r>
           </a:p>
         </p:txBody>
@@ -6504,7 +6504,7 @@
           <a:p>
             <a:r>
               <a:rPr sz="2600"/>
-              <a:t>Step 2: Route the window events to the driver (Lines 300 to 304)</a:t>
+              <a:t>Step 2: Route the window events to the driver (Lines 339 to 342)</a:t>
             </a:r>
           </a:p>
         </p:txBody>
@@ -6534,7 +6534,7 @@
           <a:lstStyle/>
           <a:p>
             <a:r>
-              <a:rPr sz="1400">
+              <a:rPr sz="1000">
                 <a:solidFill>
                   <a:srgbClr val="CCCCCC"/>
                 </a:solidFill>
@@ -6545,7 +6545,7 @@
           </a:p>
           <a:p>
             <a:r>
-              <a:rPr sz="1400">
+              <a:rPr sz="1000">
                 <a:solidFill>
                   <a:srgbClr val="CCCCCC"/>
                 </a:solidFill>
@@ -6556,35 +6556,24 @@
           </a:p>
           <a:p>
             <a:r>
-              <a:rPr sz="1400">
-                <a:solidFill>
-                  <a:srgbClr val="CCCCCC"/>
-                </a:solidFill>
-                <a:latin typeface="Consolas"/>
-              </a:rPr>
-              <a:t>if INPUT_SOURCE == "keyboard":</a:t>
-            </a:r>
-          </a:p>
-          <a:p>
-            <a:r>
-              <a:rPr sz="1400">
-                <a:solidFill>
-                  <a:srgbClr val="CCCCCC"/>
-                </a:solidFill>
-                <a:latin typeface="Consolas"/>
-              </a:rPr>
-              <a:t>    vis.AttachDriver(driver)  # route Irrlicht key events to the driver</a:t>
-            </a:r>
-          </a:p>
-          <a:p>
-            <a:r>
-              <a:rPr sz="1400">
-                <a:solidFill>
-                  <a:srgbClr val="CCCCCC"/>
-                </a:solidFill>
-                <a:latin typeface="Consolas"/>
-              </a:rPr>
-              <a:t> </a:t>
+              <a:rPr sz="1000">
+                <a:solidFill>
+                  <a:srgbClr val="CCCCCC"/>
+                </a:solidFill>
+                <a:latin typeface="Consolas"/>
+              </a:rPr>
+              <a:t>if INPUT_SOURCE in ("keyboard", "gamepad"):</a:t>
+            </a:r>
+          </a:p>
+          <a:p>
+            <a:r>
+              <a:rPr sz="1000">
+                <a:solidFill>
+                  <a:srgbClr val="CCCCCC"/>
+                </a:solidFill>
+                <a:latin typeface="Consolas"/>
+              </a:rPr>
+              <a:t>    vis.AttachDriver(driver)  # route Irrlicht key/joystick events to the driver</a:t>
             </a:r>
           </a:p>
         </p:txBody>

</xml_diff>

<commit_message>
Fix stale line numbers and code across the whole deck, verified line-by-line
Many Part 1 slides (and the two Part 5 slides) still showed line numbers
and, in two cases, actual code content (comment text, "hmmwv." instead of
"vehicle_model.") from before the Part 5 and native-joystick reworks -
they reference main()'s body, which both reworks touched heavily, and
had never been revisited. Wrote a verification pass that diffs every
code slide's shown text against the real file at its claimed line range
(dedent-aware) and fixed every mismatch it found; all 18 code slides now
match exactly.

Co-Authored-By: Claude Sonnet 5 <noreply@anthropic.com>
</commit_message>
<xml_diff>
--- a/tutorial_HIL_driver.pptx
+++ b/tutorial_HIL_driver.pptx
@@ -4943,7 +4943,7 @@
           <a:p>
             <a:r>
               <a:rPr sz="2600"/>
-              <a:t>Step 4: Enforce real time, three ways (Lines 306 to 311)</a:t>
+              <a:t>Step 4: Enforce real time, three ways (Lines 357 to 362)</a:t>
             </a:r>
           </a:p>
         </p:txBody>
@@ -5181,7 +5181,7 @@
           <a:p>
             <a:r>
               <a:rPr sz="2600"/>
-              <a:t>Step 4: Spin at the end of the loop (Lines 370 to 374)</a:t>
+              <a:t>Step 4: Spin at the end of the loop (Lines 421 to 425)</a:t>
             </a:r>
           </a:p>
         </p:txBody>
@@ -5411,7 +5411,7 @@
           <a:p>
             <a:r>
               <a:rPr sz="2600"/>
-              <a:t>Step 4: A drift-free timer in 10 lines (Lines 53 to 71)</a:t>
+              <a:t>Step 4: A drift-free timer in 10 lines (Lines 56 to 74)</a:t>
             </a:r>
           </a:p>
         </p:txBody>
@@ -12138,7 +12138,7 @@
           <a:lstStyle/>
           <a:p>
             <a:r>
-              <a:t>Choose your car (Lines 284 to 292)</a:t>
+              <a:t>Choose your car (Lines 256 to 264)</a:t>
             </a:r>
           </a:p>
         </p:txBody>
@@ -12386,7 +12386,7 @@
           <a:lstStyle/>
           <a:p>
             <a:r>
-              <a:t>Add or remove overlay pieces (Lines 365 to 372)</a:t>
+              <a:t>Add or remove overlay pieces (Lines 347 to 354)</a:t>
             </a:r>
           </a:p>
         </p:txBody>
@@ -13563,7 +13563,7 @@
           <a:p>
             <a:r>
               <a:rPr sz="2600"/>
-              <a:t>Configuration: scripted driver, as fast as possible (Lines 381 to 399)</a:t>
+              <a:t>Configuration: scripted driver, as fast as possible (Lines 435 to 453)</a:t>
             </a:r>
           </a:p>
         </p:txBody>
@@ -13593,7 +13593,7 @@
           <a:lstStyle/>
           <a:p>
             <a:r>
-              <a:rPr sz="1400">
+              <a:rPr sz="1000">
                 <a:solidFill>
                   <a:srgbClr val="CCCCCC"/>
                 </a:solidFill>
@@ -13604,7 +13604,7 @@
           </a:p>
           <a:p>
             <a:r>
-              <a:rPr sz="1400">
+              <a:rPr sz="1000">
                 <a:solidFill>
                   <a:srgbClr val="CCCCCC"/>
                 </a:solidFill>
@@ -13615,7 +13615,7 @@
           </a:p>
           <a:p>
             <a:r>
-              <a:rPr sz="1400">
+              <a:rPr sz="1000">
                 <a:solidFill>
                   <a:srgbClr val="CCCCCC"/>
                 </a:solidFill>
@@ -13626,29 +13626,29 @@
           </a:p>
           <a:p>
             <a:r>
-              <a:rPr sz="1400">
-                <a:solidFill>
-                  <a:srgbClr val="CCCCCC"/>
-                </a:solidFill>
-                <a:latin typeface="Consolas"/>
-              </a:rPr>
-              <a:t>#   "udp"       PART 3 - operator_console.py sends packets over the network</a:t>
-            </a:r>
-          </a:p>
-          <a:p>
-            <a:r>
-              <a:rPr sz="1400">
-                <a:solidFill>
-                  <a:srgbClr val="CCCCCC"/>
-                </a:solidFill>
-                <a:latin typeface="Consolas"/>
-              </a:rPr>
-              <a:t>#   "gamepad"   PART 3 - gamepad / steering wheel through pygame</a:t>
-            </a:r>
-          </a:p>
-          <a:p>
-            <a:r>
-              <a:rPr sz="1400">
+              <a:rPr sz="1000">
+                <a:solidFill>
+                  <a:srgbClr val="CCCCCC"/>
+                </a:solidFill>
+                <a:latin typeface="Consolas"/>
+              </a:rPr>
+              <a:t>#   "gamepad"   PART 3 - a joystick/wheel, read natively (JOYSTICK_CONFIG below)</a:t>
+            </a:r>
+          </a:p>
+          <a:p>
+            <a:r>
+              <a:rPr sz="1000">
+                <a:solidFill>
+                  <a:srgbClr val="CCCCCC"/>
+                </a:solidFill>
+                <a:latin typeface="Consolas"/>
+              </a:rPr>
+              <a:t>#   "udp"       PART 4 - operator_console.py sends packets over the network</a:t>
+            </a:r>
+          </a:p>
+          <a:p>
+            <a:r>
+              <a:rPr sz="1000">
                 <a:solidFill>
                   <a:srgbClr val="CCCCCC"/>
                 </a:solidFill>
@@ -13659,7 +13659,7 @@
           </a:p>
           <a:p>
             <a:r>
-              <a:rPr sz="1400">
+              <a:rPr sz="1000">
                 <a:solidFill>
                   <a:srgbClr val="CCCCCC"/>
                 </a:solidFill>
@@ -13670,7 +13670,7 @@
           </a:p>
           <a:p>
             <a:r>
-              <a:rPr sz="1400">
+              <a:rPr sz="1000">
                 <a:solidFill>
                   <a:srgbClr val="CCCCCC"/>
                 </a:solidFill>
@@ -13681,7 +13681,7 @@
           </a:p>
           <a:p>
             <a:r>
-              <a:rPr sz="1400">
+              <a:rPr sz="1000">
                 <a:solidFill>
                   <a:srgbClr val="CCCCCC"/>
                 </a:solidFill>
@@ -13692,7 +13692,7 @@
           </a:p>
           <a:p>
             <a:r>
-              <a:rPr sz="1400">
+              <a:rPr sz="1000">
                 <a:solidFill>
                   <a:srgbClr val="CCCCCC"/>
                 </a:solidFill>
@@ -13703,18 +13703,18 @@
           </a:p>
           <a:p>
             <a:r>
-              <a:rPr sz="1400">
-                <a:solidFill>
-                  <a:srgbClr val="CCCCCC"/>
-                </a:solidFill>
-                <a:latin typeface="Consolas"/>
-              </a:rPr>
-              <a:t># PART 4: send telemetry back to the operator (udp/gamepad sources only)</a:t>
-            </a:r>
-          </a:p>
-          <a:p>
-            <a:r>
-              <a:rPr sz="1400">
+              <a:rPr sz="1000">
+                <a:solidFill>
+                  <a:srgbClr val="CCCCCC"/>
+                </a:solidFill>
+                <a:latin typeface="Consolas"/>
+              </a:rPr>
+              <a:t># PART 4: send telemetry back to the operator (udp source only)</a:t>
+            </a:r>
+          </a:p>
+          <a:p>
+            <a:r>
+              <a:rPr sz="1000">
                 <a:solidFill>
                   <a:srgbClr val="CCCCCC"/>
                 </a:solidFill>
@@ -13725,7 +13725,7 @@
           </a:p>
           <a:p>
             <a:r>
-              <a:rPr sz="1400">
+              <a:rPr sz="1000">
                 <a:solidFill>
                   <a:srgbClr val="CCCCCC"/>
                 </a:solidFill>
@@ -13736,7 +13736,7 @@
           </a:p>
           <a:p>
             <a:r>
-              <a:rPr sz="1400">
+              <a:rPr sz="1000">
                 <a:solidFill>
                   <a:srgbClr val="CCCCCC"/>
                 </a:solidFill>
@@ -13747,7 +13747,7 @@
           </a:p>
           <a:p>
             <a:r>
-              <a:rPr sz="1400">
+              <a:rPr sz="1000">
                 <a:solidFill>
                   <a:srgbClr val="CCCCCC"/>
                 </a:solidFill>
@@ -13758,7 +13758,7 @@
           </a:p>
           <a:p>
             <a:r>
-              <a:rPr sz="1400">
+              <a:rPr sz="1000">
                 <a:solidFill>
                   <a:srgbClr val="CCCCCC"/>
                 </a:solidFill>
@@ -13769,7 +13769,7 @@
           </a:p>
           <a:p>
             <a:r>
-              <a:rPr sz="1400">
+              <a:rPr sz="1000">
                 <a:solidFill>
                   <a:srgbClr val="CCCCCC"/>
                 </a:solidFill>
@@ -13780,7 +13780,7 @@
           </a:p>
           <a:p>
             <a:r>
-              <a:rPr sz="1400">
+              <a:rPr sz="1000">
                 <a:solidFill>
                   <a:srgbClr val="CCCCCC"/>
                 </a:solidFill>
@@ -13791,7 +13791,7 @@
           </a:p>
           <a:p>
             <a:r>
-              <a:rPr sz="1400">
+              <a:rPr sz="1000">
                 <a:solidFill>
                   <a:srgbClr val="CCCCCC"/>
                 </a:solidFill>
@@ -13937,7 +13937,7 @@
           <a:p>
             <a:r>
               <a:rPr sz="2600"/>
-              <a:t>Step 1: A scripted ChDataDriver (Lines 252 to 262)</a:t>
+              <a:t>Step 1: A scripted ChDataDriver (Lines 284 to 294)</a:t>
             </a:r>
           </a:p>
         </p:txBody>
@@ -14223,7 +14223,7 @@
           <a:p>
             <a:r>
               <a:rPr sz="2600"/>
-              <a:t>Step 2: The simulation loop (Lines 325 to 353)</a:t>
+              <a:t>Step 2: The simulation loop (Lines 376 to 404)</a:t>
             </a:r>
           </a:p>
         </p:txBody>
@@ -14358,7 +14358,7 @@
                 </a:solidFill>
                 <a:latin typeface="Consolas"/>
               </a:rPr>
-              <a:t>    # PART 3: sample the device ONCE per step and hold it for the step</a:t>
+              <a:t>    # PART 4: sample the device ONCE per step and hold it for the step</a:t>
             </a:r>
           </a:p>
           <a:p>
@@ -14490,7 +14490,7 @@
                 </a:solidFill>
                 <a:latin typeface="Consolas"/>
               </a:rPr>
-              <a:t>    hmmwv.Synchronize(sim_time, driver_inputs, terrain)</a:t>
+              <a:t>    vehicle_model.Synchronize(sim_time, driver_inputs, terrain)</a:t>
             </a:r>
           </a:p>
           <a:p>
@@ -14556,7 +14556,7 @@
                 </a:solidFill>
                 <a:latin typeface="Consolas"/>
               </a:rPr>
-              <a:t>    hmmwv.Advance(step_size)  # spins here if REALTIME == "vehicle"</a:t>
+              <a:t>    vehicle_model.Advance(step_size)  # spins here if REALTIME == "vehicle"</a:t>
             </a:r>
           </a:p>
           <a:p>
@@ -14714,7 +14714,7 @@
           <a:p>
             <a:r>
               <a:rPr sz="2600"/>
-              <a:t>Step 3: Measure it - sim time vs wall time (Lines 355 to 361)</a:t>
+              <a:t>Step 3: Measure it - sim time vs wall time (Lines 406 to 412)</a:t>
             </a:r>
           </a:p>
         </p:txBody>

</xml_diff>

<commit_message>
Fix oversized code boxes and re-crop the overlay screenshot
The code_slide() builder hardcoded a 5537200 EMU box height copied from
the original 35-line template slide, so every shorter code excerpt I
added (Part 3, Part 5) got the same oversized black box with the note
box left far below the actual text. Resized each to fit its line count
and moved the note box to sit just below it, matching how the deck's
original hand-authored slides are laid out.

Also re-cropped the Part 5 overlay screenshot: the console and the
vehicle occupy overlapping horizontal regions in the source image, so
no rectangular crop could show the full vehicle without also showing
part of the console. Cropped to just the built-in HUD panel instead,
which is what the slide is actually illustrating.

Co-Authored-By: Claude Sonnet 5 <noreply@anthropic.com>
</commit_message>
<xml_diff>
--- a/tutorial_HIL_driver.pptx
+++ b/tutorial_HIL_driver.pptx
@@ -7477,7 +7477,7 @@
         <p:spPr>
           <a:xfrm>
             <a:off x="0" y="1050000"/>
-            <a:ext cx="12192000" cy="5537200"/>
+            <a:ext cx="12192000" cy="2130000"/>
           </a:xfrm>
           <a:prstGeom prst="rect">
             <a:avLst/>
@@ -7589,7 +7589,7 @@
         </p:nvSpPr>
         <p:spPr>
           <a:xfrm>
-            <a:off x="400000" y="6687200"/>
+            <a:off x="400000" y="3280000"/>
             <a:ext cx="11392000" cy="-229200"/>
           </a:xfrm>
           <a:prstGeom prst="rect">
@@ -7714,7 +7714,7 @@
         <p:spPr>
           <a:xfrm>
             <a:off x="0" y="1050000"/>
-            <a:ext cx="12192000" cy="5537200"/>
+            <a:ext cx="12192000" cy="1425000"/>
           </a:xfrm>
           <a:prstGeom prst="rect">
             <a:avLst/>
@@ -7793,7 +7793,7 @@
         </p:nvSpPr>
         <p:spPr>
           <a:xfrm>
-            <a:off x="400000" y="6687200"/>
+            <a:off x="400000" y="2575000"/>
             <a:ext cx="11392000" cy="-229200"/>
           </a:xfrm>
           <a:prstGeom prst="rect">
@@ -12152,7 +12152,7 @@
         <p:spPr>
           <a:xfrm>
             <a:off x="0" y="1050000"/>
-            <a:ext cx="12192000" cy="5537200"/>
+            <a:ext cx="12192000" cy="2365000"/>
           </a:xfrm>
           <a:prstGeom prst="rect">
             <a:avLst/>
@@ -12275,7 +12275,7 @@
         </p:nvSpPr>
         <p:spPr>
           <a:xfrm>
-            <a:off x="400000" y="6687200"/>
+            <a:off x="400000" y="3515000"/>
             <a:ext cx="11392000" cy="-229200"/>
           </a:xfrm>
           <a:prstGeom prst="rect">
@@ -12400,7 +12400,7 @@
         <p:spPr>
           <a:xfrm>
             <a:off x="0" y="1050000"/>
-            <a:ext cx="12192000" cy="5537200"/>
+            <a:ext cx="12192000" cy="2130000"/>
           </a:xfrm>
           <a:prstGeom prst="rect">
             <a:avLst/>
@@ -12512,7 +12512,7 @@
         </p:nvSpPr>
         <p:spPr>
           <a:xfrm>
-            <a:off x="400000" y="6687200"/>
+            <a:off x="400000" y="3280000"/>
             <a:ext cx="11392000" cy="-229200"/>
           </a:xfrm>
           <a:prstGeom prst="rect">
@@ -12866,22 +12866,22 @@
       </p:sp>
       <p:pic>
         <p:nvPicPr>
-          <p:cNvPr id="6" name="Picture 5" descr="hud_crop.png"/>
+          <p:cNvPr id="6" name="Picture 5" descr="overlay_hud.png"/>
           <p:cNvPicPr>
             <a:picLocks noChangeAspect="1"/>
           </p:cNvPicPr>
           <p:nvPr/>
         </p:nvPicPr>
         <p:blipFill>
-          <a:blip r:embed="rId2"/>
+          <a:blip r:embed="rId3"/>
           <a:stretch>
             <a:fillRect/>
           </a:stretch>
         </p:blipFill>
         <p:spPr>
           <a:xfrm>
-            <a:off x="4837089" y="3350000"/>
-            <a:ext cx="2517822" cy="3100000"/>
+            <a:off x="4196000" y="3450000"/>
+            <a:ext cx="3800000" cy="2571428"/>
           </a:xfrm>
           <a:prstGeom prst="rect">
             <a:avLst/>

</xml_diff>

<commit_message>
Fix negative-height note textboxes (invalid per OOXML spec)
Copied a negative cy value from the original template's note box
verbatim into every custom-built slide; negative dimensions are
out-of-spec for <a:ext> and a plausible contributor to PowerPoint
flagging the file for repair. Set a sane positive height instead.

Co-Authored-By: Claude Sonnet 5 <noreply@anthropic.com>
</commit_message>
<xml_diff>
--- a/tutorial_HIL_driver.pptx
+++ b/tutorial_HIL_driver.pptx
@@ -7590,7 +7590,7 @@
         <p:spPr>
           <a:xfrm>
             <a:off x="400000" y="3280000"/>
-            <a:ext cx="11392000" cy="-229200"/>
+            <a:ext cx="11392000" cy="400000"/>
           </a:xfrm>
           <a:prstGeom prst="rect">
             <a:avLst/>
@@ -7794,7 +7794,7 @@
         <p:spPr>
           <a:xfrm>
             <a:off x="400000" y="2575000"/>
-            <a:ext cx="11392000" cy="-229200"/>
+            <a:ext cx="11392000" cy="400000"/>
           </a:xfrm>
           <a:prstGeom prst="rect">
             <a:avLst/>
@@ -8927,7 +8927,7 @@
         <p:spPr>
           <a:xfrm>
             <a:off x="400000" y="6687200"/>
-            <a:ext cx="11392000" cy="-229200"/>
+            <a:ext cx="11392000" cy="400000"/>
           </a:xfrm>
           <a:prstGeom prst="rect">
             <a:avLst/>
@@ -9651,7 +9651,7 @@
         <p:spPr>
           <a:xfrm>
             <a:off x="400000" y="6534800"/>
-            <a:ext cx="11392000" cy="-76800"/>
+            <a:ext cx="11392000" cy="400000"/>
           </a:xfrm>
           <a:prstGeom prst="rect">
             <a:avLst/>
@@ -12276,7 +12276,7 @@
         <p:spPr>
           <a:xfrm>
             <a:off x="400000" y="3515000"/>
-            <a:ext cx="11392000" cy="-229200"/>
+            <a:ext cx="11392000" cy="400000"/>
           </a:xfrm>
           <a:prstGeom prst="rect">
             <a:avLst/>
@@ -12513,7 +12513,7 @@
         <p:spPr>
           <a:xfrm>
             <a:off x="400000" y="3280000"/>
-            <a:ext cx="11392000" cy="-229200"/>
+            <a:ext cx="11392000" cy="400000"/>
           </a:xfrm>
           <a:prstGeom prst="rect">
             <a:avLst/>

</xml_diff>

<commit_message>
Fix the two longest code slides overflowing past the slide bottom
35 and 34 lines of 10pt code left only ~230000-380000 EMU of margin
below the box on a 7.5in-tall slide - not enough room for the note
text, which rendered overlapping the code and the footer. Dropped
those two slides (only) to 9pt for both code and note, recomputed
their box heights/positions with a real margin instead of running
right up against the slide edge.

Co-Authored-By: Claude Sonnet 5 <noreply@anthropic.com>
</commit_message>
<xml_diff>
--- a/tutorial_HIL_driver.pptx
+++ b/tutorial_HIL_driver.pptx
@@ -8516,8 +8516,8 @@
         </p:nvSpPr>
         <p:spPr>
           <a:xfrm>
-            <a:off x="0" y="1050000"/>
-            <a:ext cx="12192000" cy="5537200"/>
+            <a:off x="0" y="980000"/>
+            <a:ext cx="12192000" cy="4983475"/>
           </a:xfrm>
           <a:prstGeom prst="rect">
             <a:avLst/>
@@ -8533,7 +8533,7 @@
           <a:lstStyle/>
           <a:p>
             <a:r>
-              <a:rPr sz="1000">
+              <a:rPr sz="900">
                 <a:solidFill>
                   <a:srgbClr val="CCCCCC"/>
                 </a:solidFill>
@@ -8544,7 +8544,7 @@
           </a:p>
           <a:p>
             <a:r>
-              <a:rPr sz="1000">
+              <a:rPr sz="900">
                 <a:solidFill>
                   <a:srgbClr val="CCCCCC"/>
                 </a:solidFill>
@@ -8555,7 +8555,7 @@
           </a:p>
           <a:p>
             <a:r>
-              <a:rPr sz="1000">
+              <a:rPr sz="900">
                 <a:solidFill>
                   <a:srgbClr val="CCCCCC"/>
                 </a:solidFill>
@@ -8566,7 +8566,7 @@
           </a:p>
           <a:p>
             <a:r>
-              <a:rPr sz="1000">
+              <a:rPr sz="900">
                 <a:solidFill>
                   <a:srgbClr val="CCCCCC"/>
                 </a:solidFill>
@@ -8577,7 +8577,7 @@
           </a:p>
           <a:p>
             <a:r>
-              <a:rPr sz="1000">
+              <a:rPr sz="900">
                 <a:solidFill>
                   <a:srgbClr val="CCCCCC"/>
                 </a:solidFill>
@@ -8588,7 +8588,7 @@
           </a:p>
           <a:p>
             <a:r>
-              <a:rPr sz="1000">
+              <a:rPr sz="900">
                 <a:solidFill>
                   <a:srgbClr val="CCCCCC"/>
                 </a:solidFill>
@@ -8599,7 +8599,7 @@
           </a:p>
           <a:p>
             <a:r>
-              <a:rPr sz="1000">
+              <a:rPr sz="900">
                 <a:solidFill>
                   <a:srgbClr val="CCCCCC"/>
                 </a:solidFill>
@@ -8610,7 +8610,7 @@
           </a:p>
           <a:p>
             <a:r>
-              <a:rPr sz="1000">
+              <a:rPr sz="900">
                 <a:solidFill>
                   <a:srgbClr val="CCCCCC"/>
                 </a:solidFill>
@@ -8621,7 +8621,7 @@
           </a:p>
           <a:p>
             <a:r>
-              <a:rPr sz="1000">
+              <a:rPr sz="900">
                 <a:solidFill>
                   <a:srgbClr val="CCCCCC"/>
                 </a:solidFill>
@@ -8632,7 +8632,7 @@
           </a:p>
           <a:p>
             <a:r>
-              <a:rPr sz="1000">
+              <a:rPr sz="900">
                 <a:solidFill>
                   <a:srgbClr val="CCCCCC"/>
                 </a:solidFill>
@@ -8643,7 +8643,7 @@
           </a:p>
           <a:p>
             <a:r>
-              <a:rPr sz="1000">
+              <a:rPr sz="900">
                 <a:solidFill>
                   <a:srgbClr val="CCCCCC"/>
                 </a:solidFill>
@@ -8654,7 +8654,7 @@
           </a:p>
           <a:p>
             <a:r>
-              <a:rPr sz="1000">
+              <a:rPr sz="900">
                 <a:solidFill>
                   <a:srgbClr val="CCCCCC"/>
                 </a:solidFill>
@@ -8665,7 +8665,7 @@
           </a:p>
           <a:p>
             <a:r>
-              <a:rPr sz="1000">
+              <a:rPr sz="900">
                 <a:solidFill>
                   <a:srgbClr val="CCCCCC"/>
                 </a:solidFill>
@@ -8676,7 +8676,7 @@
           </a:p>
           <a:p>
             <a:r>
-              <a:rPr sz="1000">
+              <a:rPr sz="900">
                 <a:solidFill>
                   <a:srgbClr val="CCCCCC"/>
                 </a:solidFill>
@@ -8687,7 +8687,7 @@
           </a:p>
           <a:p>
             <a:r>
-              <a:rPr sz="1000">
+              <a:rPr sz="900">
                 <a:solidFill>
                   <a:srgbClr val="CCCCCC"/>
                 </a:solidFill>
@@ -8698,7 +8698,7 @@
           </a:p>
           <a:p>
             <a:r>
-              <a:rPr sz="1000">
+              <a:rPr sz="900">
                 <a:solidFill>
                   <a:srgbClr val="CCCCCC"/>
                 </a:solidFill>
@@ -8709,7 +8709,7 @@
           </a:p>
           <a:p>
             <a:r>
-              <a:rPr sz="1000">
+              <a:rPr sz="900">
                 <a:solidFill>
                   <a:srgbClr val="CCCCCC"/>
                 </a:solidFill>
@@ -8720,7 +8720,7 @@
           </a:p>
           <a:p>
             <a:r>
-              <a:rPr sz="1000">
+              <a:rPr sz="900">
                 <a:solidFill>
                   <a:srgbClr val="CCCCCC"/>
                 </a:solidFill>
@@ -8731,7 +8731,7 @@
           </a:p>
           <a:p>
             <a:r>
-              <a:rPr sz="1000">
+              <a:rPr sz="900">
                 <a:solidFill>
                   <a:srgbClr val="CCCCCC"/>
                 </a:solidFill>
@@ -8742,7 +8742,7 @@
           </a:p>
           <a:p>
             <a:r>
-              <a:rPr sz="1000">
+              <a:rPr sz="900">
                 <a:solidFill>
                   <a:srgbClr val="CCCCCC"/>
                 </a:solidFill>
@@ -8753,7 +8753,7 @@
           </a:p>
           <a:p>
             <a:r>
-              <a:rPr sz="1000">
+              <a:rPr sz="900">
                 <a:solidFill>
                   <a:srgbClr val="CCCCCC"/>
                 </a:solidFill>
@@ -8764,7 +8764,7 @@
           </a:p>
           <a:p>
             <a:r>
-              <a:rPr sz="1000">
+              <a:rPr sz="900">
                 <a:solidFill>
                   <a:srgbClr val="CCCCCC"/>
                 </a:solidFill>
@@ -8775,7 +8775,7 @@
           </a:p>
           <a:p>
             <a:r>
-              <a:rPr sz="1000">
+              <a:rPr sz="900">
                 <a:solidFill>
                   <a:srgbClr val="CCCCCC"/>
                 </a:solidFill>
@@ -8786,7 +8786,7 @@
           </a:p>
           <a:p>
             <a:r>
-              <a:rPr sz="1000">
+              <a:rPr sz="900">
                 <a:solidFill>
                   <a:srgbClr val="CCCCCC"/>
                 </a:solidFill>
@@ -8797,7 +8797,7 @@
           </a:p>
           <a:p>
             <a:r>
-              <a:rPr sz="1000">
+              <a:rPr sz="900">
                 <a:solidFill>
                   <a:srgbClr val="CCCCCC"/>
                 </a:solidFill>
@@ -8808,7 +8808,7 @@
           </a:p>
           <a:p>
             <a:r>
-              <a:rPr sz="1000">
+              <a:rPr sz="900">
                 <a:solidFill>
                   <a:srgbClr val="CCCCCC"/>
                 </a:solidFill>
@@ -8819,7 +8819,7 @@
           </a:p>
           <a:p>
             <a:r>
-              <a:rPr sz="1000">
+              <a:rPr sz="900">
                 <a:solidFill>
                   <a:srgbClr val="CCCCCC"/>
                 </a:solidFill>
@@ -8830,7 +8830,7 @@
           </a:p>
           <a:p>
             <a:r>
-              <a:rPr sz="1000">
+              <a:rPr sz="900">
                 <a:solidFill>
                   <a:srgbClr val="CCCCCC"/>
                 </a:solidFill>
@@ -8841,7 +8841,7 @@
           </a:p>
           <a:p>
             <a:r>
-              <a:rPr sz="1000">
+              <a:rPr sz="900">
                 <a:solidFill>
                   <a:srgbClr val="CCCCCC"/>
                 </a:solidFill>
@@ -8852,7 +8852,7 @@
           </a:p>
           <a:p>
             <a:r>
-              <a:rPr sz="1000">
+              <a:rPr sz="900">
                 <a:solidFill>
                   <a:srgbClr val="CCCCCC"/>
                 </a:solidFill>
@@ -8863,7 +8863,7 @@
           </a:p>
           <a:p>
             <a:r>
-              <a:rPr sz="1000">
+              <a:rPr sz="900">
                 <a:solidFill>
                   <a:srgbClr val="CCCCCC"/>
                 </a:solidFill>
@@ -8874,7 +8874,7 @@
           </a:p>
           <a:p>
             <a:r>
-              <a:rPr sz="1000">
+              <a:rPr sz="900">
                 <a:solidFill>
                   <a:srgbClr val="CCCCCC"/>
                 </a:solidFill>
@@ -8885,7 +8885,7 @@
           </a:p>
           <a:p>
             <a:r>
-              <a:rPr sz="1000">
+              <a:rPr sz="900">
                 <a:solidFill>
                   <a:srgbClr val="CCCCCC"/>
                 </a:solidFill>
@@ -8896,7 +8896,7 @@
           </a:p>
           <a:p>
             <a:r>
-              <a:rPr sz="1000">
+              <a:rPr sz="900">
                 <a:solidFill>
                   <a:srgbClr val="CCCCCC"/>
                 </a:solidFill>
@@ -8907,7 +8907,7 @@
           </a:p>
           <a:p>
             <a:r>
-              <a:rPr sz="1000">
+              <a:rPr sz="900">
                 <a:solidFill>
                   <a:srgbClr val="CCCCCC"/>
                 </a:solidFill>
@@ -8926,8 +8926,8 @@
         </p:nvSpPr>
         <p:spPr>
           <a:xfrm>
-            <a:off x="400000" y="6687200"/>
-            <a:ext cx="11392000" cy="400000"/>
+            <a:off x="400000" y="6003475"/>
+            <a:ext cx="11392000" cy="260000"/>
           </a:xfrm>
           <a:prstGeom prst="rect">
             <a:avLst/>
@@ -8942,7 +8942,7 @@
           <a:p>
             <a:pPr/>
             <a:r>
-              <a:rPr sz="1800"/>
+              <a:rPr sz="1600"/>
               <a:t>Same first-order lag as ChInteractiveDriver::SetGains, in Python, so all devices behave alike</a:t>
             </a:r>
           </a:p>
@@ -9251,8 +9251,8 @@
         </p:nvSpPr>
         <p:spPr>
           <a:xfrm>
-            <a:off x="0" y="1050000"/>
-            <a:ext cx="12192000" cy="5384800"/>
+            <a:off x="0" y="980000"/>
+            <a:ext cx="12192000" cy="4841090"/>
           </a:xfrm>
           <a:prstGeom prst="rect">
             <a:avLst/>
@@ -9268,7 +9268,7 @@
           <a:lstStyle/>
           <a:p>
             <a:r>
-              <a:rPr sz="1000">
+              <a:rPr sz="900">
                 <a:solidFill>
                   <a:srgbClr val="CCCCCC"/>
                 </a:solidFill>
@@ -9279,7 +9279,7 @@
           </a:p>
           <a:p>
             <a:r>
-              <a:rPr sz="1000">
+              <a:rPr sz="900">
                 <a:solidFill>
                   <a:srgbClr val="CCCCCC"/>
                 </a:solidFill>
@@ -9290,7 +9290,7 @@
           </a:p>
           <a:p>
             <a:r>
-              <a:rPr sz="1000">
+              <a:rPr sz="900">
                 <a:solidFill>
                   <a:srgbClr val="CCCCCC"/>
                 </a:solidFill>
@@ -9301,7 +9301,7 @@
           </a:p>
           <a:p>
             <a:r>
-              <a:rPr sz="1000">
+              <a:rPr sz="900">
                 <a:solidFill>
                   <a:srgbClr val="CCCCCC"/>
                 </a:solidFill>
@@ -9312,7 +9312,7 @@
           </a:p>
           <a:p>
             <a:r>
-              <a:rPr sz="1000">
+              <a:rPr sz="900">
                 <a:solidFill>
                   <a:srgbClr val="CCCCCC"/>
                 </a:solidFill>
@@ -9323,7 +9323,7 @@
           </a:p>
           <a:p>
             <a:r>
-              <a:rPr sz="1000">
+              <a:rPr sz="900">
                 <a:solidFill>
                   <a:srgbClr val="CCCCCC"/>
                 </a:solidFill>
@@ -9334,7 +9334,7 @@
           </a:p>
           <a:p>
             <a:r>
-              <a:rPr sz="1000">
+              <a:rPr sz="900">
                 <a:solidFill>
                   <a:srgbClr val="CCCCCC"/>
                 </a:solidFill>
@@ -9345,7 +9345,7 @@
           </a:p>
           <a:p>
             <a:r>
-              <a:rPr sz="1000">
+              <a:rPr sz="900">
                 <a:solidFill>
                   <a:srgbClr val="CCCCCC"/>
                 </a:solidFill>
@@ -9356,7 +9356,7 @@
           </a:p>
           <a:p>
             <a:r>
-              <a:rPr sz="1000">
+              <a:rPr sz="900">
                 <a:solidFill>
                   <a:srgbClr val="CCCCCC"/>
                 </a:solidFill>
@@ -9367,7 +9367,7 @@
           </a:p>
           <a:p>
             <a:r>
-              <a:rPr sz="1000">
+              <a:rPr sz="900">
                 <a:solidFill>
                   <a:srgbClr val="CCCCCC"/>
                 </a:solidFill>
@@ -9378,7 +9378,7 @@
           </a:p>
           <a:p>
             <a:r>
-              <a:rPr sz="1000">
+              <a:rPr sz="900">
                 <a:solidFill>
                   <a:srgbClr val="CCCCCC"/>
                 </a:solidFill>
@@ -9389,7 +9389,7 @@
           </a:p>
           <a:p>
             <a:r>
-              <a:rPr sz="1000">
+              <a:rPr sz="900">
                 <a:solidFill>
                   <a:srgbClr val="CCCCCC"/>
                 </a:solidFill>
@@ -9400,7 +9400,7 @@
           </a:p>
           <a:p>
             <a:r>
-              <a:rPr sz="1000">
+              <a:rPr sz="900">
                 <a:solidFill>
                   <a:srgbClr val="CCCCCC"/>
                 </a:solidFill>
@@ -9411,7 +9411,7 @@
           </a:p>
           <a:p>
             <a:r>
-              <a:rPr sz="1000">
+              <a:rPr sz="900">
                 <a:solidFill>
                   <a:srgbClr val="CCCCCC"/>
                 </a:solidFill>
@@ -9422,7 +9422,7 @@
           </a:p>
           <a:p>
             <a:r>
-              <a:rPr sz="1000">
+              <a:rPr sz="900">
                 <a:solidFill>
                   <a:srgbClr val="CCCCCC"/>
                 </a:solidFill>
@@ -9433,7 +9433,7 @@
           </a:p>
           <a:p>
             <a:r>
-              <a:rPr sz="1000">
+              <a:rPr sz="900">
                 <a:solidFill>
                   <a:srgbClr val="CCCCCC"/>
                 </a:solidFill>
@@ -9444,7 +9444,7 @@
           </a:p>
           <a:p>
             <a:r>
-              <a:rPr sz="1000">
+              <a:rPr sz="900">
                 <a:solidFill>
                   <a:srgbClr val="CCCCCC"/>
                 </a:solidFill>
@@ -9455,7 +9455,7 @@
           </a:p>
           <a:p>
             <a:r>
-              <a:rPr sz="1000">
+              <a:rPr sz="900">
                 <a:solidFill>
                   <a:srgbClr val="CCCCCC"/>
                 </a:solidFill>
@@ -9466,7 +9466,7 @@
           </a:p>
           <a:p>
             <a:r>
-              <a:rPr sz="1000">
+              <a:rPr sz="900">
                 <a:solidFill>
                   <a:srgbClr val="CCCCCC"/>
                 </a:solidFill>
@@ -9477,7 +9477,7 @@
           </a:p>
           <a:p>
             <a:r>
-              <a:rPr sz="1000">
+              <a:rPr sz="900">
                 <a:solidFill>
                   <a:srgbClr val="CCCCCC"/>
                 </a:solidFill>
@@ -9488,7 +9488,7 @@
           </a:p>
           <a:p>
             <a:r>
-              <a:rPr sz="1000">
+              <a:rPr sz="900">
                 <a:solidFill>
                   <a:srgbClr val="CCCCCC"/>
                 </a:solidFill>
@@ -9499,7 +9499,7 @@
           </a:p>
           <a:p>
             <a:r>
-              <a:rPr sz="1000">
+              <a:rPr sz="900">
                 <a:solidFill>
                   <a:srgbClr val="CCCCCC"/>
                 </a:solidFill>
@@ -9510,7 +9510,7 @@
           </a:p>
           <a:p>
             <a:r>
-              <a:rPr sz="1000">
+              <a:rPr sz="900">
                 <a:solidFill>
                   <a:srgbClr val="CCCCCC"/>
                 </a:solidFill>
@@ -9521,7 +9521,7 @@
           </a:p>
           <a:p>
             <a:r>
-              <a:rPr sz="1000">
+              <a:rPr sz="900">
                 <a:solidFill>
                   <a:srgbClr val="CCCCCC"/>
                 </a:solidFill>
@@ -9532,7 +9532,7 @@
           </a:p>
           <a:p>
             <a:r>
-              <a:rPr sz="1000">
+              <a:rPr sz="900">
                 <a:solidFill>
                   <a:srgbClr val="CCCCCC"/>
                 </a:solidFill>
@@ -9543,7 +9543,7 @@
           </a:p>
           <a:p>
             <a:r>
-              <a:rPr sz="1000">
+              <a:rPr sz="900">
                 <a:solidFill>
                   <a:srgbClr val="CCCCCC"/>
                 </a:solidFill>
@@ -9554,7 +9554,7 @@
           </a:p>
           <a:p>
             <a:r>
-              <a:rPr sz="1000">
+              <a:rPr sz="900">
                 <a:solidFill>
                   <a:srgbClr val="CCCCCC"/>
                 </a:solidFill>
@@ -9565,7 +9565,7 @@
           </a:p>
           <a:p>
             <a:r>
-              <a:rPr sz="1000">
+              <a:rPr sz="900">
                 <a:solidFill>
                   <a:srgbClr val="CCCCCC"/>
                 </a:solidFill>
@@ -9576,7 +9576,7 @@
           </a:p>
           <a:p>
             <a:r>
-              <a:rPr sz="1000">
+              <a:rPr sz="900">
                 <a:solidFill>
                   <a:srgbClr val="CCCCCC"/>
                 </a:solidFill>
@@ -9587,7 +9587,7 @@
           </a:p>
           <a:p>
             <a:r>
-              <a:rPr sz="1000">
+              <a:rPr sz="900">
                 <a:solidFill>
                   <a:srgbClr val="CCCCCC"/>
                 </a:solidFill>
@@ -9598,7 +9598,7 @@
           </a:p>
           <a:p>
             <a:r>
-              <a:rPr sz="1000">
+              <a:rPr sz="900">
                 <a:solidFill>
                   <a:srgbClr val="CCCCCC"/>
                 </a:solidFill>
@@ -9609,7 +9609,7 @@
           </a:p>
           <a:p>
             <a:r>
-              <a:rPr sz="1000">
+              <a:rPr sz="900">
                 <a:solidFill>
                   <a:srgbClr val="CCCCCC"/>
                 </a:solidFill>
@@ -9620,7 +9620,7 @@
           </a:p>
           <a:p>
             <a:r>
-              <a:rPr sz="1000">
+              <a:rPr sz="900">
                 <a:solidFill>
                   <a:srgbClr val="CCCCCC"/>
                 </a:solidFill>
@@ -9631,7 +9631,7 @@
           </a:p>
           <a:p>
             <a:r>
-              <a:rPr sz="1000">
+              <a:rPr sz="900">
                 <a:solidFill>
                   <a:srgbClr val="CCCCCC"/>
                 </a:solidFill>
@@ -9650,8 +9650,8 @@
         </p:nvSpPr>
         <p:spPr>
           <a:xfrm>
-            <a:off x="400000" y="6534800"/>
-            <a:ext cx="11392000" cy="400000"/>
+            <a:off x="400000" y="5861090"/>
+            <a:ext cx="11392000" cy="260000"/>
           </a:xfrm>
           <a:prstGeom prst="rect">
             <a:avLst/>
@@ -9666,14 +9666,14 @@
           <a:p>
             <a:pPr/>
             <a:r>
-              <a:rPr sz="1800"/>
+              <a:rPr sz="1600"/>
               <a:t>Non-blocking socket, drained every step; the newest packet wins, an empty queue holds the last value</a:t>
             </a:r>
           </a:p>
           <a:p>
             <a:pPr/>
             <a:r>
-              <a:rPr sz="1800"/>
+              <a:rPr sz="1600"/>
               <a:t>The operator can be anywhere on the network - and the console has no Chrono dependency at all</a:t>
             </a:r>
           </a:p>

</xml_diff>

<commit_message>
Fix diagram text contrast, sedan distortion, and drop CityBus for UAZBUS
Diagram box labels were black text on dark navy fill; sedan screenshot
was captured too close and looked stretched; CityBus clipped or looked
cut off at every chase distance tried, so it's replaced with UAZBUS
(regularly sized, no clipping) in build_vehicle(), docs, and the
vehicle grid image.

Co-Authored-By: Claude Sonnet 5 <noreply@anthropic.com>
</commit_message>
<xml_diff>
--- a/tutorial_HIL_driver.pptx
+++ b/tutorial_HIL_driver.pptx
@@ -8333,14 +8333,22 @@
           <a:p>
             <a:pPr algn="ctr"/>
             <a:r>
-              <a:rPr sz="1800" b="1"/>
+              <a:rPr sz="1800" b="1">
+                <a:solidFill>
+                  <a:srgbClr val="FFFFFF"/>
+                </a:solidFill>
+              </a:rPr>
               <a:t>Operator machine</a:t>
             </a:r>
           </a:p>
           <a:p>
             <a:pPr algn="ctr"/>
             <a:r>
-              <a:rPr sz="1800"/>
+              <a:rPr sz="1800">
+                <a:solidFill>
+                  <a:srgbClr val="FFFFFF"/>
+                </a:solidFill>
+              </a:rPr>
               <a:t>operator_console.py</a:t>
             </a:r>
           </a:p>
@@ -8375,14 +8383,22 @@
           <a:p>
             <a:pPr algn="ctr"/>
             <a:r>
-              <a:rPr sz="1800" b="1"/>
+              <a:rPr sz="1800" b="1">
+                <a:solidFill>
+                  <a:srgbClr val="FFFFFF"/>
+                </a:solidFill>
+              </a:rPr>
               <a:t>Simulation machine</a:t>
             </a:r>
           </a:p>
           <a:p>
             <a:pPr algn="ctr"/>
             <a:r>
-              <a:rPr sz="1800"/>
+              <a:rPr sz="1800">
+                <a:solidFill>
+                  <a:srgbClr val="FFFFFF"/>
+                </a:solidFill>
+              </a:rPr>
               <a:t>tutorial_HIL_driver.py</a:t>
             </a:r>
           </a:p>
@@ -12267,7 +12283,7 @@
             <a:pPr/>
             <a:r>
               <a:rPr sz="2000"/>
-              <a:t>Every full-vehicle model in Chrono::Vehicle (HMMWV_Full, Sedan, CityBus, Gator, ...) shares the same interface</a:t>
+              <a:t>Every full-vehicle model in Chrono::Vehicle (HMMWV_Full, Sedan, UAZBUS, Gator, ...) shares the same interface</a:t>
             </a:r>
           </a:p>
           <a:p>
@@ -12433,14 +12449,74 @@
           </a:p>
         </p:txBody>
       </p:sp>
+      <p:sp>
+        <p:nvSpPr>
+          <p:cNvPr id="4" name="TextBox 3"/>
+          <p:cNvSpPr txBox="1"/>
+          <p:nvPr/>
+        </p:nvSpPr>
+        <p:spPr>
+          <a:xfrm>
+            <a:off x="310974" y="6645811"/>
+            <a:ext cx="11644805" cy="188527"/>
+          </a:xfrm>
+          <a:prstGeom prst="rect">
+            <a:avLst/>
+          </a:prstGeom>
+          <a:noFill/>
+        </p:spPr>
+        <p:txBody>
+          <a:bodyPr wrap="none">
+            <a:spAutoFit/>
+          </a:bodyPr>
+          <a:lstStyle/>
+          <a:p>
+            <a:r>
+              <a:rPr sz="1000"/>
+              <a:t>University of Wisconsin - Madison</a:t>
+            </a:r>
+          </a:p>
+        </p:txBody>
+      </p:sp>
+      <p:sp>
+        <p:nvSpPr>
+          <p:cNvPr id="5" name="TextBox 4"/>
+          <p:cNvSpPr txBox="1"/>
+          <p:nvPr/>
+        </p:nvSpPr>
+        <p:spPr>
+          <a:xfrm>
+            <a:off x="10249563" y="6646310"/>
+            <a:ext cx="1706217" cy="188028"/>
+          </a:xfrm>
+          <a:prstGeom prst="rect">
+            <a:avLst/>
+          </a:prstGeom>
+          <a:noFill/>
+        </p:spPr>
+        <p:txBody>
+          <a:bodyPr wrap="none">
+            <a:spAutoFit/>
+          </a:bodyPr>
+          <a:lstStyle/>
+          <a:p>
+            <a:r>
+              <a:rPr sz="1000"/>
+              <a:t>43</a:t>
+            </a:r>
+          </a:p>
+        </p:txBody>
+      </p:sp>
       <p:pic>
         <p:nvPicPr>
-          <p:cNvPr id="3" name="Picture 1"/>
-          <p:cNvPicPr/>
+          <p:cNvPr id="6" name="Picture 5" descr="vehicle_grid.png"/>
+          <p:cNvPicPr>
+            <a:picLocks noChangeAspect="1"/>
+          </p:cNvPicPr>
           <p:nvPr/>
         </p:nvPicPr>
         <p:blipFill>
-          <a:blip r:embed="rId2"/>
+          <a:blip r:embed="rId3"/>
           <a:stretch>
             <a:fillRect/>
           </a:stretch>
@@ -12455,64 +12531,6 @@
           </a:prstGeom>
         </p:spPr>
       </p:pic>
-      <p:sp>
-        <p:nvSpPr>
-          <p:cNvPr id="4" name="TextBox 3"/>
-          <p:cNvSpPr txBox="1"/>
-          <p:nvPr/>
-        </p:nvSpPr>
-        <p:spPr>
-          <a:xfrm>
-            <a:off x="310974" y="6645811"/>
-            <a:ext cx="11644805" cy="188527"/>
-          </a:xfrm>
-          <a:prstGeom prst="rect">
-            <a:avLst/>
-          </a:prstGeom>
-          <a:noFill/>
-        </p:spPr>
-        <p:txBody>
-          <a:bodyPr wrap="none">
-            <a:spAutoFit/>
-          </a:bodyPr>
-          <a:lstStyle/>
-          <a:p>
-            <a:r>
-              <a:rPr sz="1000"/>
-              <a:t>University of Wisconsin - Madison</a:t>
-            </a:r>
-          </a:p>
-        </p:txBody>
-      </p:sp>
-      <p:sp>
-        <p:nvSpPr>
-          <p:cNvPr id="5" name="TextBox 4"/>
-          <p:cNvSpPr txBox="1"/>
-          <p:nvPr/>
-        </p:nvSpPr>
-        <p:spPr>
-          <a:xfrm>
-            <a:off x="10249563" y="6646310"/>
-            <a:ext cx="1706217" cy="188028"/>
-          </a:xfrm>
-          <a:prstGeom prst="rect">
-            <a:avLst/>
-          </a:prstGeom>
-          <a:noFill/>
-        </p:spPr>
-        <p:txBody>
-          <a:bodyPr wrap="none">
-            <a:spAutoFit/>
-          </a:bodyPr>
-          <a:lstStyle/>
-          <a:p>
-            <a:r>
-              <a:rPr sz="1000"/>
-              <a:t>43</a:t>
-            </a:r>
-          </a:p>
-        </p:txBody>
-      </p:sp>
     </p:spTree>
   </p:cSld>
   <p:clrMapOvr>
@@ -12698,7 +12716,7 @@
           <a:p>
             <a:r>
               <a:rPr sz="1800"/>
-              <a:t>VEHICLE lives in CONFIGURATION - "hmmwv" | "sedan" | "citybus" | "gator"; everything below this line is unchanged</a:t>
+              <a:t>VEHICLE lives in CONFIGURATION - "hmmwv" | "sedan" | "uazbus" | "gator"; everything below this line is unchanged</a:t>
             </a:r>
           </a:p>
         </p:txBody>
@@ -13057,7 +13075,7 @@
             <a:pPr/>
             <a:r>
               <a:rPr sz="2000"/>
-              <a:t>Set VEHICLE = "citybus" (or "sedan", "gator") and re-run - same driver, same terrain, very different vehicle</a:t>
+              <a:t>Set VEHICLE = "uazbus" (or "sedan", "gator") and re-run - same driver, same terrain, very different vehicle</a:t>
             </a:r>
           </a:p>
           <a:p>

</xml_diff>

<commit_message>
Reposition Part 5 as bonus material, not the core lesson
The real-time-correctness (Part 1) and closing-the-loop (Part 4) content
is the reusable pattern; choosing a vehicle and tweaking the overlay
(Part 5) is a cosmetic bonus. Flag that explicitly in the README, the
overview slide's Part 5 bullet, and a new subtitle on the Part 5 divider
slide, so the talk doesn't read as five equally-weighted parts.

Co-Authored-By: Claude Sonnet 5 <noreply@anthropic.com>
</commit_message>
<xml_diff>
--- a/tutorial_HIL_driver.pptx
+++ b/tutorial_HIL_driver.pptx
@@ -6920,7 +6920,7 @@
             <a:pPr lvl="1"/>
             <a:r>
               <a:rPr sz="1800"/>
-              <a:t>PART 5: Customize the built-in overlay and choose your car</a:t>
+              <a:t>PART 5 (bonus): Customize the built-in overlay and choose your car -- cosmetic, not the core lesson</a:t>
             </a:r>
           </a:p>
           <a:p>
@@ -12163,7 +12163,11 @@
         <p:txBody>
           <a:bodyPr/>
           <a:lstStyle/>
-          <a:p/>
+          <a:p>
+            <a:r>
+              <a:t>Bonus material: the car picker and overlay flags are nice-to-haves. Parts 1 and 4 are the patterns worth taking with you.</a:t>
+            </a:r>
+          </a:p>
         </p:txBody>
       </p:sp>
       <p:sp>

</xml_diff>